<commit_message>
Fixed login screenshot (removed NameError UI) and updated PPTX
</commit_message>
<xml_diff>
--- a/VernaLedger_Full_Presentation.pptx
+++ b/VernaLedger_Full_Presentation.pptx
@@ -3327,7 +3327,7 @@
               </a:defRPr>
             </a:pPr>
             <a:r>
-              <a:t>• Authentication Security: PBKDF2 with SHA-256 password hashing.</a:t>
+              <a:t>• Authentication Security: PBKDF2 with SHA-256.</a:t>
             </a:r>
           </a:p>
           <a:p>
@@ -3342,7 +3342,7 @@
               </a:defRPr>
             </a:pPr>
             <a:r>
-              <a:t>• Role-Based Access (RBAC): Admin vs. Staff roles.</a:t>
+              <a:t>• Role-Based Access (RBAC): Admin vs. Staff.</a:t>
             </a:r>
           </a:p>
           <a:p>
@@ -3595,7 +3595,7 @@
               </a:defRPr>
             </a:pPr>
             <a:r>
-              <a:t>• Duplicate Prevention: Automatic system warnings.</a:t>
+              <a:t>• Duplicate Prevention: Automatic warnings.</a:t>
             </a:r>
           </a:p>
           <a:p>
@@ -3610,7 +3610,7 @@
               </a:defRPr>
             </a:pPr>
             <a:r>
-              <a:t>• Audio Confirmation: Edge TTS synthesizes audio in Marathi.</a:t>
+              <a:t>• Audio Confirmation: Edge TTS in Marathi.</a:t>
             </a:r>
           </a:p>
         </p:txBody>
@@ -3833,7 +3833,7 @@
               </a:defRPr>
             </a:pPr>
             <a:r>
-              <a:t>• Sales Monitoring: Live KPI cards for Total Revenue.</a:t>
+              <a:t>• Sales Monitoring: Live KPI cards.</a:t>
             </a:r>
           </a:p>
           <a:p>
@@ -3863,7 +3863,7 @@
               </a:defRPr>
             </a:pPr>
             <a:r>
-              <a:t>• Timeframe Filtering: Daily, Weekly, and Monthly insights.</a:t>
+              <a:t>• Timeframe Filtering: Daily, Weekly, Monthly.</a:t>
             </a:r>
           </a:p>
         </p:txBody>
@@ -4086,7 +4086,7 @@
               </a:defRPr>
             </a:pPr>
             <a:r>
-              <a:t>• Digital Ledger: Toggle Given Credit &amp; Received Payment.</a:t>
+              <a:t>• Digital Ledger: Toggle Given &amp; Received.</a:t>
             </a:r>
           </a:p>
           <a:p>
@@ -4116,7 +4116,7 @@
               </a:defRPr>
             </a:pPr>
             <a:r>
-              <a:t>• One-Click Follow Up: WhatsApp payment links &amp; calling.</a:t>
+              <a:t>• One-Click Follow Up: WhatsApp links.</a:t>
             </a:r>
           </a:p>
         </p:txBody>
@@ -4339,7 +4339,7 @@
               </a:defRPr>
             </a:pPr>
             <a:r>
-              <a:t>• ACID Storage &amp; Live Editing: Interactive dataframe.</a:t>
+              <a:t>• ACID Storage &amp; Live Editing: Interactive grid.</a:t>
             </a:r>
           </a:p>
           <a:p>
@@ -4354,7 +4354,7 @@
               </a:defRPr>
             </a:pPr>
             <a:r>
-              <a:t>• Record Management: Secure deletions with live commits.</a:t>
+              <a:t>• Record Management: Secure deletions.</a:t>
             </a:r>
           </a:p>
           <a:p>
@@ -4369,7 +4369,7 @@
               </a:defRPr>
             </a:pPr>
             <a:r>
-              <a:t>• Multi-Language Export: Download CSV or Marathi PDF.</a:t>
+              <a:t>• Multi-Language Export: CSV or Marathi PDF.</a:t>
             </a:r>
           </a:p>
         </p:txBody>
@@ -4592,7 +4592,7 @@
               </a:defRPr>
             </a:pPr>
             <a:r>
-              <a:t>• Context-Aware Chatbot: Chat with sales &amp; khata context.</a:t>
+              <a:t>• Context-Aware Chatbot: Chat with context.</a:t>
             </a:r>
           </a:p>
           <a:p>
@@ -4607,7 +4607,7 @@
               </a:defRPr>
             </a:pPr>
             <a:r>
-              <a:t>• Voice Input: Ask questions in Marathi or Hindi.</a:t>
+              <a:t>• Voice Input: Ask in Marathi or Hindi.</a:t>
             </a:r>
           </a:p>
           <a:p>
@@ -4622,7 +4622,7 @@
               </a:defRPr>
             </a:pPr>
             <a:r>
-              <a:t>• Quick Action Chips: One-tap prompts for insights.</a:t>
+              <a:t>• Quick Action Chips: One-tap prompts.</a:t>
             </a:r>
           </a:p>
         </p:txBody>
@@ -4845,7 +4845,7 @@
               </a:defRPr>
             </a:pPr>
             <a:r>
-              <a:t>• Role Access Setup: Easy wizard for Admin or Staff.</a:t>
+              <a:t>• Role Access Setup: Wizard for Admin or Staff.</a:t>
             </a:r>
           </a:p>
           <a:p>
@@ -4860,7 +4860,7 @@
               </a:defRPr>
             </a:pPr>
             <a:r>
-              <a:t>• System Audit Logs: Tracks 'Who did what and when'.</a:t>
+              <a:t>• System Audit Logs: Tracks 'Who did what'.</a:t>
             </a:r>
           </a:p>
           <a:p>
@@ -4875,7 +4875,7 @@
               </a:defRPr>
             </a:pPr>
             <a:r>
-              <a:t>• Zero-Trust Security: Protects core system against deletions.</a:t>
+              <a:t>• Zero-Trust Security: Protects core system.</a:t>
             </a:r>
           </a:p>
         </p:txBody>

</xml_diff>

<commit_message>
Fix sidebar collapse icon ligature, Staff Management language & audit cleanup, and presentation styles
</commit_message>
<xml_diff>
--- a/VernaLedger_Full_Presentation.pptx
+++ b/VernaLedger_Full_Presentation.pptx
@@ -3128,7 +3128,7 @@
           <a:p/>
           <a:p>
             <a:pPr algn="ctr">
-              <a:defRPr sz="6000" b="1">
+              <a:defRPr sz="6200" b="1">
                 <a:solidFill>
                   <a:srgbClr val="00F2FE"/>
                 </a:solidFill>
@@ -3164,7 +3164,7 @@
           <a:p/>
           <a:p>
             <a:pPr algn="ctr">
-              <a:defRPr sz="2800">
+              <a:defRPr sz="3000">
                 <a:solidFill>
                   <a:srgbClr val="00FF87"/>
                 </a:solidFill>
@@ -3247,7 +3247,7 @@
           </a:p>
           <a:p>
             <a:pPr algn="ctr">
-              <a:defRPr sz="3200" b="1">
+              <a:defRPr sz="3600" b="1">
                 <a:solidFill>
                   <a:srgbClr val="00F2FE"/>
                 </a:solidFill>
@@ -3304,13 +3304,21 @@
           </a:p>
           <a:p>
             <a:pPr>
-              <a:defRPr sz="2200" b="1">
+              <a:spcAft>
+                <a:spcPts val="1600"/>
+              </a:spcAft>
+              <a:defRPr sz="2400" b="1">
                 <a:solidFill>
                   <a:srgbClr val="FFFFFF"/>
                 </a:solidFill>
               </a:defRPr>
             </a:pPr>
             <a:r>
+              <a:rPr sz="2400" b="1">
+                <a:solidFill>
+                  <a:srgbClr val="00FF87"/>
+                </a:solidFill>
+              </a:rPr>
               <a:t>Access Management</a:t>
             </a:r>
           </a:p>
@@ -3320,14 +3328,27 @@
               <a:spcAft>
                 <a:spcPts val="1400"/>
               </a:spcAft>
-              <a:defRPr sz="1600">
+              <a:defRPr sz="2000">
                 <a:solidFill>
                   <a:srgbClr val="C8C8C8"/>
                 </a:solidFill>
               </a:defRPr>
             </a:pPr>
             <a:r>
-              <a:t>• Authentication Security: PBKDF2 with SHA-256.</a:t>
+              <a:rPr sz="2000" b="1">
+                <a:solidFill>
+                  <a:srgbClr val="00F2FE"/>
+                </a:solidFill>
+              </a:rPr>
+              <a:t>• Authentication Security: </a:t>
+            </a:r>
+            <a:r>
+              <a:rPr sz="2000" b="0">
+                <a:solidFill>
+                  <a:srgbClr val="F1F5F9"/>
+                </a:solidFill>
+              </a:rPr>
+              <a:t>PBKDF2 with SHA-256.</a:t>
             </a:r>
           </a:p>
           <a:p>
@@ -3335,14 +3356,27 @@
               <a:spcAft>
                 <a:spcPts val="1400"/>
               </a:spcAft>
-              <a:defRPr sz="1600">
+              <a:defRPr sz="2000">
                 <a:solidFill>
                   <a:srgbClr val="C8C8C8"/>
                 </a:solidFill>
               </a:defRPr>
             </a:pPr>
             <a:r>
-              <a:t>• Role-Based Access (RBAC): Admin vs. Staff.</a:t>
+              <a:rPr sz="2000" b="1">
+                <a:solidFill>
+                  <a:srgbClr val="00F2FE"/>
+                </a:solidFill>
+              </a:rPr>
+              <a:t>• Role-Based Access (RBAC): </a:t>
+            </a:r>
+            <a:r>
+              <a:rPr sz="2000" b="0">
+                <a:solidFill>
+                  <a:srgbClr val="F1F5F9"/>
+                </a:solidFill>
+              </a:rPr>
+              <a:t>Admin vs. Staff.</a:t>
             </a:r>
           </a:p>
           <a:p>
@@ -3350,14 +3384,27 @@
               <a:spcAft>
                 <a:spcPts val="1400"/>
               </a:spcAft>
-              <a:defRPr sz="1600">
+              <a:defRPr sz="2000">
                 <a:solidFill>
                   <a:srgbClr val="C8C8C8"/>
                 </a:solidFill>
               </a:defRPr>
             </a:pPr>
             <a:r>
-              <a:t>• Persistent Sessions: Auto-login functionality.</a:t>
+              <a:rPr sz="2000" b="1">
+                <a:solidFill>
+                  <a:srgbClr val="00F2FE"/>
+                </a:solidFill>
+              </a:rPr>
+              <a:t>• Persistent Sessions: </a:t>
+            </a:r>
+            <a:r>
+              <a:rPr sz="2000" b="0">
+                <a:solidFill>
+                  <a:srgbClr val="F1F5F9"/>
+                </a:solidFill>
+              </a:rPr>
+              <a:t>Auto-login functionality.</a:t>
             </a:r>
           </a:p>
         </p:txBody>
@@ -3500,7 +3547,7 @@
           </a:p>
           <a:p>
             <a:pPr algn="ctr">
-              <a:defRPr sz="3200" b="1">
+              <a:defRPr sz="3600" b="1">
                 <a:solidFill>
                   <a:srgbClr val="00F2FE"/>
                 </a:solidFill>
@@ -3557,13 +3604,21 @@
           </a:p>
           <a:p>
             <a:pPr>
-              <a:defRPr sz="2200" b="1">
+              <a:spcAft>
+                <a:spcPts val="1600"/>
+              </a:spcAft>
+              <a:defRPr sz="2400" b="1">
                 <a:solidFill>
                   <a:srgbClr val="FFFFFF"/>
                 </a:solidFill>
               </a:defRPr>
             </a:pPr>
             <a:r>
+              <a:rPr sz="2400" b="1">
+                <a:solidFill>
+                  <a:srgbClr val="00FF87"/>
+                </a:solidFill>
+              </a:rPr>
               <a:t>Core Engine Showcase</a:t>
             </a:r>
           </a:p>
@@ -3573,14 +3628,27 @@
               <a:spcAft>
                 <a:spcPts val="1400"/>
               </a:spcAft>
-              <a:defRPr sz="1600">
+              <a:defRPr sz="2000">
                 <a:solidFill>
                   <a:srgbClr val="C8C8C8"/>
                 </a:solidFill>
               </a:defRPr>
             </a:pPr>
             <a:r>
-              <a:t>• Multimodal Bill Capture: File Upload, Camera, Voice.</a:t>
+              <a:rPr sz="2000" b="1">
+                <a:solidFill>
+                  <a:srgbClr val="00F2FE"/>
+                </a:solidFill>
+              </a:rPr>
+              <a:t>• Multimodal Bill Capture: </a:t>
+            </a:r>
+            <a:r>
+              <a:rPr sz="2000" b="0">
+                <a:solidFill>
+                  <a:srgbClr val="F1F5F9"/>
+                </a:solidFill>
+              </a:rPr>
+              <a:t>File Upload, Camera, Voice.</a:t>
             </a:r>
           </a:p>
           <a:p>
@@ -3588,14 +3656,27 @@
               <a:spcAft>
                 <a:spcPts val="1400"/>
               </a:spcAft>
-              <a:defRPr sz="1600">
+              <a:defRPr sz="2000">
                 <a:solidFill>
                   <a:srgbClr val="C8C8C8"/>
                 </a:solidFill>
               </a:defRPr>
             </a:pPr>
             <a:r>
-              <a:t>• Duplicate Prevention: Automatic warnings.</a:t>
+              <a:rPr sz="2000" b="1">
+                <a:solidFill>
+                  <a:srgbClr val="00F2FE"/>
+                </a:solidFill>
+              </a:rPr>
+              <a:t>• Duplicate Prevention: </a:t>
+            </a:r>
+            <a:r>
+              <a:rPr sz="2000" b="0">
+                <a:solidFill>
+                  <a:srgbClr val="F1F5F9"/>
+                </a:solidFill>
+              </a:rPr>
+              <a:t>Automatic warnings.</a:t>
             </a:r>
           </a:p>
           <a:p>
@@ -3603,14 +3684,27 @@
               <a:spcAft>
                 <a:spcPts val="1400"/>
               </a:spcAft>
-              <a:defRPr sz="1600">
+              <a:defRPr sz="2000">
                 <a:solidFill>
                   <a:srgbClr val="C8C8C8"/>
                 </a:solidFill>
               </a:defRPr>
             </a:pPr>
             <a:r>
-              <a:t>• Audio Confirmation: Edge TTS in Marathi.</a:t>
+              <a:rPr sz="2000" b="1">
+                <a:solidFill>
+                  <a:srgbClr val="00F2FE"/>
+                </a:solidFill>
+              </a:rPr>
+              <a:t>• Audio Confirmation: </a:t>
+            </a:r>
+            <a:r>
+              <a:rPr sz="2000" b="0">
+                <a:solidFill>
+                  <a:srgbClr val="F1F5F9"/>
+                </a:solidFill>
+              </a:rPr>
+              <a:t>Edge TTS in Marathi.</a:t>
             </a:r>
           </a:p>
         </p:txBody>
@@ -3753,7 +3847,7 @@
           </a:p>
           <a:p>
             <a:pPr algn="ctr">
-              <a:defRPr sz="3200" b="1">
+              <a:defRPr sz="3600" b="1">
                 <a:solidFill>
                   <a:srgbClr val="00F2FE"/>
                 </a:solidFill>
@@ -3810,13 +3904,21 @@
           </a:p>
           <a:p>
             <a:pPr>
-              <a:defRPr sz="2200" b="1">
+              <a:spcAft>
+                <a:spcPts val="1600"/>
+              </a:spcAft>
+              <a:defRPr sz="2400" b="1">
                 <a:solidFill>
                   <a:srgbClr val="FFFFFF"/>
                 </a:solidFill>
               </a:defRPr>
             </a:pPr>
             <a:r>
+              <a:rPr sz="2400" b="1">
+                <a:solidFill>
+                  <a:srgbClr val="00FF87"/>
+                </a:solidFill>
+              </a:rPr>
               <a:t>Data Intelligence</a:t>
             </a:r>
           </a:p>
@@ -3826,14 +3928,27 @@
               <a:spcAft>
                 <a:spcPts val="1400"/>
               </a:spcAft>
-              <a:defRPr sz="1600">
+              <a:defRPr sz="2000">
                 <a:solidFill>
                   <a:srgbClr val="C8C8C8"/>
                 </a:solidFill>
               </a:defRPr>
             </a:pPr>
             <a:r>
-              <a:t>• Sales Monitoring: Live KPI cards.</a:t>
+              <a:rPr sz="2000" b="1">
+                <a:solidFill>
+                  <a:srgbClr val="00F2FE"/>
+                </a:solidFill>
+              </a:rPr>
+              <a:t>• Sales Monitoring: </a:t>
+            </a:r>
+            <a:r>
+              <a:rPr sz="2000" b="0">
+                <a:solidFill>
+                  <a:srgbClr val="F1F5F9"/>
+                </a:solidFill>
+              </a:rPr>
+              <a:t>Live KPI cards.</a:t>
             </a:r>
           </a:p>
           <a:p>
@@ -3841,14 +3956,27 @@
               <a:spcAft>
                 <a:spcPts val="1400"/>
               </a:spcAft>
-              <a:defRPr sz="1600">
+              <a:defRPr sz="2000">
                 <a:solidFill>
                   <a:srgbClr val="C8C8C8"/>
                 </a:solidFill>
               </a:defRPr>
             </a:pPr>
             <a:r>
-              <a:t>• Visualizations: Interactive pies and bar graphs.</a:t>
+              <a:rPr sz="2000" b="1">
+                <a:solidFill>
+                  <a:srgbClr val="00F2FE"/>
+                </a:solidFill>
+              </a:rPr>
+              <a:t>• Visualizations: </a:t>
+            </a:r>
+            <a:r>
+              <a:rPr sz="2000" b="0">
+                <a:solidFill>
+                  <a:srgbClr val="F1F5F9"/>
+                </a:solidFill>
+              </a:rPr>
+              <a:t>Interactive pies and bar graphs.</a:t>
             </a:r>
           </a:p>
           <a:p>
@@ -3856,14 +3984,27 @@
               <a:spcAft>
                 <a:spcPts val="1400"/>
               </a:spcAft>
-              <a:defRPr sz="1600">
+              <a:defRPr sz="2000">
                 <a:solidFill>
                   <a:srgbClr val="C8C8C8"/>
                 </a:solidFill>
               </a:defRPr>
             </a:pPr>
             <a:r>
-              <a:t>• Timeframe Filtering: Daily, Weekly, Monthly.</a:t>
+              <a:rPr sz="2000" b="1">
+                <a:solidFill>
+                  <a:srgbClr val="00F2FE"/>
+                </a:solidFill>
+              </a:rPr>
+              <a:t>• Timeframe Filtering: </a:t>
+            </a:r>
+            <a:r>
+              <a:rPr sz="2000" b="0">
+                <a:solidFill>
+                  <a:srgbClr val="F1F5F9"/>
+                </a:solidFill>
+              </a:rPr>
+              <a:t>Daily, Weekly, Monthly.</a:t>
             </a:r>
           </a:p>
         </p:txBody>
@@ -4006,7 +4147,7 @@
           </a:p>
           <a:p>
             <a:pPr algn="ctr">
-              <a:defRPr sz="3200" b="1">
+              <a:defRPr sz="3600" b="1">
                 <a:solidFill>
                   <a:srgbClr val="00F2FE"/>
                 </a:solidFill>
@@ -4063,13 +4204,21 @@
           </a:p>
           <a:p>
             <a:pPr>
-              <a:defRPr sz="2200" b="1">
+              <a:spcAft>
+                <a:spcPts val="1600"/>
+              </a:spcAft>
+              <a:defRPr sz="2400" b="1">
                 <a:solidFill>
                   <a:srgbClr val="FFFFFF"/>
                 </a:solidFill>
               </a:defRPr>
             </a:pPr>
             <a:r>
+              <a:rPr sz="2400" b="1">
+                <a:solidFill>
+                  <a:srgbClr val="00FF87"/>
+                </a:solidFill>
+              </a:rPr>
               <a:t>Credit Management Dashboard</a:t>
             </a:r>
           </a:p>
@@ -4079,14 +4228,27 @@
               <a:spcAft>
                 <a:spcPts val="1400"/>
               </a:spcAft>
-              <a:defRPr sz="1600">
+              <a:defRPr sz="2000">
                 <a:solidFill>
                   <a:srgbClr val="C8C8C8"/>
                 </a:solidFill>
               </a:defRPr>
             </a:pPr>
             <a:r>
-              <a:t>• Digital Ledger: Toggle Given &amp; Received.</a:t>
+              <a:rPr sz="2000" b="1">
+                <a:solidFill>
+                  <a:srgbClr val="00F2FE"/>
+                </a:solidFill>
+              </a:rPr>
+              <a:t>• Digital Ledger: </a:t>
+            </a:r>
+            <a:r>
+              <a:rPr sz="2000" b="0">
+                <a:solidFill>
+                  <a:srgbClr val="F1F5F9"/>
+                </a:solidFill>
+              </a:rPr>
+              <a:t>Toggle Given &amp; Received.</a:t>
             </a:r>
           </a:p>
           <a:p>
@@ -4094,14 +4256,27 @@
               <a:spcAft>
                 <a:spcPts val="1400"/>
               </a:spcAft>
-              <a:defRPr sz="1600">
+              <a:defRPr sz="2000">
                 <a:solidFill>
                   <a:srgbClr val="C8C8C8"/>
                 </a:solidFill>
               </a:defRPr>
             </a:pPr>
             <a:r>
-              <a:t>• Due Date Tracking: Automated high-risk alerts.</a:t>
+              <a:rPr sz="2000" b="1">
+                <a:solidFill>
+                  <a:srgbClr val="00F2FE"/>
+                </a:solidFill>
+              </a:rPr>
+              <a:t>• Due Date Tracking: </a:t>
+            </a:r>
+            <a:r>
+              <a:rPr sz="2000" b="0">
+                <a:solidFill>
+                  <a:srgbClr val="F1F5F9"/>
+                </a:solidFill>
+              </a:rPr>
+              <a:t>Automated high-risk alerts.</a:t>
             </a:r>
           </a:p>
           <a:p>
@@ -4109,14 +4284,27 @@
               <a:spcAft>
                 <a:spcPts val="1400"/>
               </a:spcAft>
-              <a:defRPr sz="1600">
+              <a:defRPr sz="2000">
                 <a:solidFill>
                   <a:srgbClr val="C8C8C8"/>
                 </a:solidFill>
               </a:defRPr>
             </a:pPr>
             <a:r>
-              <a:t>• One-Click Follow Up: WhatsApp links.</a:t>
+              <a:rPr sz="2000" b="1">
+                <a:solidFill>
+                  <a:srgbClr val="00F2FE"/>
+                </a:solidFill>
+              </a:rPr>
+              <a:t>• One-Click Follow Up: </a:t>
+            </a:r>
+            <a:r>
+              <a:rPr sz="2000" b="0">
+                <a:solidFill>
+                  <a:srgbClr val="F1F5F9"/>
+                </a:solidFill>
+              </a:rPr>
+              <a:t>WhatsApp links.</a:t>
             </a:r>
           </a:p>
         </p:txBody>
@@ -4259,7 +4447,7 @@
           </a:p>
           <a:p>
             <a:pPr algn="ctr">
-              <a:defRPr sz="3200" b="1">
+              <a:defRPr sz="3600" b="1">
                 <a:solidFill>
                   <a:srgbClr val="00F2FE"/>
                 </a:solidFill>
@@ -4316,13 +4504,21 @@
           </a:p>
           <a:p>
             <a:pPr>
-              <a:defRPr sz="2200" b="1">
+              <a:spcAft>
+                <a:spcPts val="1600"/>
+              </a:spcAft>
+              <a:defRPr sz="2400" b="1">
                 <a:solidFill>
                   <a:srgbClr val="FFFFFF"/>
                 </a:solidFill>
               </a:defRPr>
             </a:pPr>
             <a:r>
+              <a:rPr sz="2400" b="1">
+                <a:solidFill>
+                  <a:srgbClr val="00FF87"/>
+                </a:solidFill>
+              </a:rPr>
               <a:t>Live Data Management</a:t>
             </a:r>
           </a:p>
@@ -4332,14 +4528,27 @@
               <a:spcAft>
                 <a:spcPts val="1400"/>
               </a:spcAft>
-              <a:defRPr sz="1600">
+              <a:defRPr sz="2000">
                 <a:solidFill>
                   <a:srgbClr val="C8C8C8"/>
                 </a:solidFill>
               </a:defRPr>
             </a:pPr>
             <a:r>
-              <a:t>• ACID Storage &amp; Live Editing: Interactive grid.</a:t>
+              <a:rPr sz="2000" b="1">
+                <a:solidFill>
+                  <a:srgbClr val="00F2FE"/>
+                </a:solidFill>
+              </a:rPr>
+              <a:t>• ACID Storage &amp; Live Editing: </a:t>
+            </a:r>
+            <a:r>
+              <a:rPr sz="2000" b="0">
+                <a:solidFill>
+                  <a:srgbClr val="F1F5F9"/>
+                </a:solidFill>
+              </a:rPr>
+              <a:t>Interactive grid.</a:t>
             </a:r>
           </a:p>
           <a:p>
@@ -4347,14 +4556,27 @@
               <a:spcAft>
                 <a:spcPts val="1400"/>
               </a:spcAft>
-              <a:defRPr sz="1600">
+              <a:defRPr sz="2000">
                 <a:solidFill>
                   <a:srgbClr val="C8C8C8"/>
                 </a:solidFill>
               </a:defRPr>
             </a:pPr>
             <a:r>
-              <a:t>• Record Management: Secure deletions.</a:t>
+              <a:rPr sz="2000" b="1">
+                <a:solidFill>
+                  <a:srgbClr val="00F2FE"/>
+                </a:solidFill>
+              </a:rPr>
+              <a:t>• Record Management: </a:t>
+            </a:r>
+            <a:r>
+              <a:rPr sz="2000" b="0">
+                <a:solidFill>
+                  <a:srgbClr val="F1F5F9"/>
+                </a:solidFill>
+              </a:rPr>
+              <a:t>Secure deletions.</a:t>
             </a:r>
           </a:p>
           <a:p>
@@ -4362,14 +4584,27 @@
               <a:spcAft>
                 <a:spcPts val="1400"/>
               </a:spcAft>
-              <a:defRPr sz="1600">
+              <a:defRPr sz="2000">
                 <a:solidFill>
                   <a:srgbClr val="C8C8C8"/>
                 </a:solidFill>
               </a:defRPr>
             </a:pPr>
             <a:r>
-              <a:t>• Multi-Language Export: CSV or Marathi PDF.</a:t>
+              <a:rPr sz="2000" b="1">
+                <a:solidFill>
+                  <a:srgbClr val="00F2FE"/>
+                </a:solidFill>
+              </a:rPr>
+              <a:t>• Multi-Language Export: </a:t>
+            </a:r>
+            <a:r>
+              <a:rPr sz="2000" b="0">
+                <a:solidFill>
+                  <a:srgbClr val="F1F5F9"/>
+                </a:solidFill>
+              </a:rPr>
+              <a:t>CSV or Marathi PDF.</a:t>
             </a:r>
           </a:p>
         </p:txBody>
@@ -4512,7 +4747,7 @@
           </a:p>
           <a:p>
             <a:pPr algn="ctr">
-              <a:defRPr sz="3200" b="1">
+              <a:defRPr sz="3600" b="1">
                 <a:solidFill>
                   <a:srgbClr val="00F2FE"/>
                 </a:solidFill>
@@ -4569,13 +4804,21 @@
           </a:p>
           <a:p>
             <a:pPr>
-              <a:defRPr sz="2200" b="1">
+              <a:spcAft>
+                <a:spcPts val="1600"/>
+              </a:spcAft>
+              <a:defRPr sz="2400" b="1">
                 <a:solidFill>
                   <a:srgbClr val="FFFFFF"/>
                 </a:solidFill>
               </a:defRPr>
             </a:pPr>
             <a:r>
+              <a:rPr sz="2400" b="1">
+                <a:solidFill>
+                  <a:srgbClr val="00FF87"/>
+                </a:solidFill>
+              </a:rPr>
               <a:t>Conversational Intelligence</a:t>
             </a:r>
           </a:p>
@@ -4585,14 +4828,27 @@
               <a:spcAft>
                 <a:spcPts val="1400"/>
               </a:spcAft>
-              <a:defRPr sz="1600">
+              <a:defRPr sz="2000">
                 <a:solidFill>
                   <a:srgbClr val="C8C8C8"/>
                 </a:solidFill>
               </a:defRPr>
             </a:pPr>
             <a:r>
-              <a:t>• Context-Aware Chatbot: Chat with context.</a:t>
+              <a:rPr sz="2000" b="1">
+                <a:solidFill>
+                  <a:srgbClr val="00F2FE"/>
+                </a:solidFill>
+              </a:rPr>
+              <a:t>• Context-Aware Chatbot: </a:t>
+            </a:r>
+            <a:r>
+              <a:rPr sz="2000" b="0">
+                <a:solidFill>
+                  <a:srgbClr val="F1F5F9"/>
+                </a:solidFill>
+              </a:rPr>
+              <a:t>Chat with context.</a:t>
             </a:r>
           </a:p>
           <a:p>
@@ -4600,14 +4856,27 @@
               <a:spcAft>
                 <a:spcPts val="1400"/>
               </a:spcAft>
-              <a:defRPr sz="1600">
+              <a:defRPr sz="2000">
                 <a:solidFill>
                   <a:srgbClr val="C8C8C8"/>
                 </a:solidFill>
               </a:defRPr>
             </a:pPr>
             <a:r>
-              <a:t>• Voice Input: Ask in Marathi or Hindi.</a:t>
+              <a:rPr sz="2000" b="1">
+                <a:solidFill>
+                  <a:srgbClr val="00F2FE"/>
+                </a:solidFill>
+              </a:rPr>
+              <a:t>• Voice Input: </a:t>
+            </a:r>
+            <a:r>
+              <a:rPr sz="2000" b="0">
+                <a:solidFill>
+                  <a:srgbClr val="F1F5F9"/>
+                </a:solidFill>
+              </a:rPr>
+              <a:t>Ask in Marathi or Hindi.</a:t>
             </a:r>
           </a:p>
           <a:p>
@@ -4615,14 +4884,27 @@
               <a:spcAft>
                 <a:spcPts val="1400"/>
               </a:spcAft>
-              <a:defRPr sz="1600">
+              <a:defRPr sz="2000">
                 <a:solidFill>
                   <a:srgbClr val="C8C8C8"/>
                 </a:solidFill>
               </a:defRPr>
             </a:pPr>
             <a:r>
-              <a:t>• Quick Action Chips: One-tap prompts.</a:t>
+              <a:rPr sz="2000" b="1">
+                <a:solidFill>
+                  <a:srgbClr val="00F2FE"/>
+                </a:solidFill>
+              </a:rPr>
+              <a:t>• Quick Action Chips: </a:t>
+            </a:r>
+            <a:r>
+              <a:rPr sz="2000" b="0">
+                <a:solidFill>
+                  <a:srgbClr val="F1F5F9"/>
+                </a:solidFill>
+              </a:rPr>
+              <a:t>One-tap prompts.</a:t>
             </a:r>
           </a:p>
         </p:txBody>
@@ -4765,7 +5047,7 @@
           </a:p>
           <a:p>
             <a:pPr algn="ctr">
-              <a:defRPr sz="3200" b="1">
+              <a:defRPr sz="3600" b="1">
                 <a:solidFill>
                   <a:srgbClr val="00F2FE"/>
                 </a:solidFill>
@@ -4822,13 +5104,21 @@
           </a:p>
           <a:p>
             <a:pPr>
-              <a:defRPr sz="2200" b="1">
+              <a:spcAft>
+                <a:spcPts val="1600"/>
+              </a:spcAft>
+              <a:defRPr sz="2400" b="1">
                 <a:solidFill>
                   <a:srgbClr val="FFFFFF"/>
                 </a:solidFill>
               </a:defRPr>
             </a:pPr>
             <a:r>
+              <a:rPr sz="2400" b="1">
+                <a:solidFill>
+                  <a:srgbClr val="00FF87"/>
+                </a:solidFill>
+              </a:rPr>
               <a:t>System Accountability</a:t>
             </a:r>
           </a:p>
@@ -4838,14 +5128,27 @@
               <a:spcAft>
                 <a:spcPts val="1400"/>
               </a:spcAft>
-              <a:defRPr sz="1600">
+              <a:defRPr sz="2000">
                 <a:solidFill>
                   <a:srgbClr val="C8C8C8"/>
                 </a:solidFill>
               </a:defRPr>
             </a:pPr>
             <a:r>
-              <a:t>• Role Access Setup: Wizard for Admin or Staff.</a:t>
+              <a:rPr sz="2000" b="1">
+                <a:solidFill>
+                  <a:srgbClr val="00F2FE"/>
+                </a:solidFill>
+              </a:rPr>
+              <a:t>• Role Access Setup: </a:t>
+            </a:r>
+            <a:r>
+              <a:rPr sz="2000" b="0">
+                <a:solidFill>
+                  <a:srgbClr val="F1F5F9"/>
+                </a:solidFill>
+              </a:rPr>
+              <a:t>Wizard for Admin or Staff.</a:t>
             </a:r>
           </a:p>
           <a:p>
@@ -4853,14 +5156,27 @@
               <a:spcAft>
                 <a:spcPts val="1400"/>
               </a:spcAft>
-              <a:defRPr sz="1600">
+              <a:defRPr sz="2000">
                 <a:solidFill>
                   <a:srgbClr val="C8C8C8"/>
                 </a:solidFill>
               </a:defRPr>
             </a:pPr>
             <a:r>
-              <a:t>• System Audit Logs: Tracks 'Who did what'.</a:t>
+              <a:rPr sz="2000" b="1">
+                <a:solidFill>
+                  <a:srgbClr val="00F2FE"/>
+                </a:solidFill>
+              </a:rPr>
+              <a:t>• System Audit Logs: </a:t>
+            </a:r>
+            <a:r>
+              <a:rPr sz="2000" b="0">
+                <a:solidFill>
+                  <a:srgbClr val="F1F5F9"/>
+                </a:solidFill>
+              </a:rPr>
+              <a:t>Tracks 'Who did what'.</a:t>
             </a:r>
           </a:p>
           <a:p>
@@ -4868,14 +5184,27 @@
               <a:spcAft>
                 <a:spcPts val="1400"/>
               </a:spcAft>
-              <a:defRPr sz="1600">
+              <a:defRPr sz="2000">
                 <a:solidFill>
                   <a:srgbClr val="C8C8C8"/>
                 </a:solidFill>
               </a:defRPr>
             </a:pPr>
             <a:r>
-              <a:t>• Zero-Trust Security: Protects core system.</a:t>
+              <a:rPr sz="2000" b="1">
+                <a:solidFill>
+                  <a:srgbClr val="00F2FE"/>
+                </a:solidFill>
+              </a:rPr>
+              <a:t>• Zero-Trust Security: </a:t>
+            </a:r>
+            <a:r>
+              <a:rPr sz="2000" b="0">
+                <a:solidFill>
+                  <a:srgbClr val="F1F5F9"/>
+                </a:solidFill>
+              </a:rPr>
+              <a:t>Protects core system.</a:t>
             </a:r>
           </a:p>
         </p:txBody>
@@ -4997,7 +5326,7 @@
           <a:p/>
           <a:p>
             <a:pPr algn="ctr">
-              <a:defRPr sz="5400" b="1">
+              <a:defRPr sz="5800" b="1">
                 <a:solidFill>
                   <a:srgbClr val="00F2FE"/>
                 </a:solidFill>

</xml_diff>

<commit_message>
revert: restore entire application to 7 days ago state (commit 3a33a62 on Oct 10 2026)
</commit_message>
<xml_diff>
--- a/VernaLedger_Full_Presentation.pptx
+++ b/VernaLedger_Full_Presentation.pptx
@@ -3128,7 +3128,7 @@
           <a:p/>
           <a:p>
             <a:pPr algn="ctr">
-              <a:defRPr sz="6200" b="1">
+              <a:defRPr sz="6000" b="1">
                 <a:solidFill>
                   <a:srgbClr val="00F2FE"/>
                 </a:solidFill>
@@ -3164,7 +3164,7 @@
           <a:p/>
           <a:p>
             <a:pPr algn="ctr">
-              <a:defRPr sz="3000">
+              <a:defRPr sz="2800">
                 <a:solidFill>
                   <a:srgbClr val="00FF87"/>
                 </a:solidFill>
@@ -3247,7 +3247,7 @@
           </a:p>
           <a:p>
             <a:pPr algn="ctr">
-              <a:defRPr sz="3600" b="1">
+              <a:defRPr sz="3200" b="1">
                 <a:solidFill>
                   <a:srgbClr val="00F2FE"/>
                 </a:solidFill>
@@ -3304,21 +3304,13 @@
           </a:p>
           <a:p>
             <a:pPr>
-              <a:spcAft>
-                <a:spcPts val="1600"/>
-              </a:spcAft>
-              <a:defRPr sz="2400" b="1">
+              <a:defRPr sz="2200" b="1">
                 <a:solidFill>
                   <a:srgbClr val="FFFFFF"/>
                 </a:solidFill>
               </a:defRPr>
             </a:pPr>
             <a:r>
-              <a:rPr sz="2400" b="1">
-                <a:solidFill>
-                  <a:srgbClr val="00FF87"/>
-                </a:solidFill>
-              </a:rPr>
               <a:t>Access Management</a:t>
             </a:r>
           </a:p>
@@ -3328,27 +3320,14 @@
               <a:spcAft>
                 <a:spcPts val="1400"/>
               </a:spcAft>
-              <a:defRPr sz="2000">
+              <a:defRPr sz="1600">
                 <a:solidFill>
                   <a:srgbClr val="C8C8C8"/>
                 </a:solidFill>
               </a:defRPr>
             </a:pPr>
             <a:r>
-              <a:rPr sz="2000" b="1">
-                <a:solidFill>
-                  <a:srgbClr val="00F2FE"/>
-                </a:solidFill>
-              </a:rPr>
-              <a:t>• Authentication Security: </a:t>
-            </a:r>
-            <a:r>
-              <a:rPr sz="2000" b="0">
-                <a:solidFill>
-                  <a:srgbClr val="F1F5F9"/>
-                </a:solidFill>
-              </a:rPr>
-              <a:t>PBKDF2 with SHA-256.</a:t>
+              <a:t>• Authentication Security: PBKDF2 with SHA-256.</a:t>
             </a:r>
           </a:p>
           <a:p>
@@ -3356,27 +3335,14 @@
               <a:spcAft>
                 <a:spcPts val="1400"/>
               </a:spcAft>
-              <a:defRPr sz="2000">
+              <a:defRPr sz="1600">
                 <a:solidFill>
                   <a:srgbClr val="C8C8C8"/>
                 </a:solidFill>
               </a:defRPr>
             </a:pPr>
             <a:r>
-              <a:rPr sz="2000" b="1">
-                <a:solidFill>
-                  <a:srgbClr val="00F2FE"/>
-                </a:solidFill>
-              </a:rPr>
-              <a:t>• Role-Based Access (RBAC): </a:t>
-            </a:r>
-            <a:r>
-              <a:rPr sz="2000" b="0">
-                <a:solidFill>
-                  <a:srgbClr val="F1F5F9"/>
-                </a:solidFill>
-              </a:rPr>
-              <a:t>Admin vs. Staff.</a:t>
+              <a:t>• Role-Based Access (RBAC): Admin vs. Staff.</a:t>
             </a:r>
           </a:p>
           <a:p>
@@ -3384,27 +3350,14 @@
               <a:spcAft>
                 <a:spcPts val="1400"/>
               </a:spcAft>
-              <a:defRPr sz="2000">
+              <a:defRPr sz="1600">
                 <a:solidFill>
                   <a:srgbClr val="C8C8C8"/>
                 </a:solidFill>
               </a:defRPr>
             </a:pPr>
             <a:r>
-              <a:rPr sz="2000" b="1">
-                <a:solidFill>
-                  <a:srgbClr val="00F2FE"/>
-                </a:solidFill>
-              </a:rPr>
-              <a:t>• Persistent Sessions: </a:t>
-            </a:r>
-            <a:r>
-              <a:rPr sz="2000" b="0">
-                <a:solidFill>
-                  <a:srgbClr val="F1F5F9"/>
-                </a:solidFill>
-              </a:rPr>
-              <a:t>Auto-login functionality.</a:t>
+              <a:t>• Persistent Sessions: Auto-login functionality.</a:t>
             </a:r>
           </a:p>
         </p:txBody>
@@ -3547,7 +3500,7 @@
           </a:p>
           <a:p>
             <a:pPr algn="ctr">
-              <a:defRPr sz="3600" b="1">
+              <a:defRPr sz="3200" b="1">
                 <a:solidFill>
                   <a:srgbClr val="00F2FE"/>
                 </a:solidFill>
@@ -3604,21 +3557,13 @@
           </a:p>
           <a:p>
             <a:pPr>
-              <a:spcAft>
-                <a:spcPts val="1600"/>
-              </a:spcAft>
-              <a:defRPr sz="2400" b="1">
+              <a:defRPr sz="2200" b="1">
                 <a:solidFill>
                   <a:srgbClr val="FFFFFF"/>
                 </a:solidFill>
               </a:defRPr>
             </a:pPr>
             <a:r>
-              <a:rPr sz="2400" b="1">
-                <a:solidFill>
-                  <a:srgbClr val="00FF87"/>
-                </a:solidFill>
-              </a:rPr>
               <a:t>Core Engine Showcase</a:t>
             </a:r>
           </a:p>
@@ -3628,27 +3573,14 @@
               <a:spcAft>
                 <a:spcPts val="1400"/>
               </a:spcAft>
-              <a:defRPr sz="2000">
+              <a:defRPr sz="1600">
                 <a:solidFill>
                   <a:srgbClr val="C8C8C8"/>
                 </a:solidFill>
               </a:defRPr>
             </a:pPr>
             <a:r>
-              <a:rPr sz="2000" b="1">
-                <a:solidFill>
-                  <a:srgbClr val="00F2FE"/>
-                </a:solidFill>
-              </a:rPr>
-              <a:t>• Multimodal Bill Capture: </a:t>
-            </a:r>
-            <a:r>
-              <a:rPr sz="2000" b="0">
-                <a:solidFill>
-                  <a:srgbClr val="F1F5F9"/>
-                </a:solidFill>
-              </a:rPr>
-              <a:t>File Upload, Camera, Voice.</a:t>
+              <a:t>• Multimodal Bill Capture: File Upload, Camera, Voice.</a:t>
             </a:r>
           </a:p>
           <a:p>
@@ -3656,27 +3588,14 @@
               <a:spcAft>
                 <a:spcPts val="1400"/>
               </a:spcAft>
-              <a:defRPr sz="2000">
+              <a:defRPr sz="1600">
                 <a:solidFill>
                   <a:srgbClr val="C8C8C8"/>
                 </a:solidFill>
               </a:defRPr>
             </a:pPr>
             <a:r>
-              <a:rPr sz="2000" b="1">
-                <a:solidFill>
-                  <a:srgbClr val="00F2FE"/>
-                </a:solidFill>
-              </a:rPr>
-              <a:t>• Duplicate Prevention: </a:t>
-            </a:r>
-            <a:r>
-              <a:rPr sz="2000" b="0">
-                <a:solidFill>
-                  <a:srgbClr val="F1F5F9"/>
-                </a:solidFill>
-              </a:rPr>
-              <a:t>Automatic warnings.</a:t>
+              <a:t>• Duplicate Prevention: Automatic warnings.</a:t>
             </a:r>
           </a:p>
           <a:p>
@@ -3684,27 +3603,14 @@
               <a:spcAft>
                 <a:spcPts val="1400"/>
               </a:spcAft>
-              <a:defRPr sz="2000">
+              <a:defRPr sz="1600">
                 <a:solidFill>
                   <a:srgbClr val="C8C8C8"/>
                 </a:solidFill>
               </a:defRPr>
             </a:pPr>
             <a:r>
-              <a:rPr sz="2000" b="1">
-                <a:solidFill>
-                  <a:srgbClr val="00F2FE"/>
-                </a:solidFill>
-              </a:rPr>
-              <a:t>• Audio Confirmation: </a:t>
-            </a:r>
-            <a:r>
-              <a:rPr sz="2000" b="0">
-                <a:solidFill>
-                  <a:srgbClr val="F1F5F9"/>
-                </a:solidFill>
-              </a:rPr>
-              <a:t>Edge TTS in Marathi.</a:t>
+              <a:t>• Audio Confirmation: Edge TTS in Marathi.</a:t>
             </a:r>
           </a:p>
         </p:txBody>
@@ -3847,7 +3753,7 @@
           </a:p>
           <a:p>
             <a:pPr algn="ctr">
-              <a:defRPr sz="3600" b="1">
+              <a:defRPr sz="3200" b="1">
                 <a:solidFill>
                   <a:srgbClr val="00F2FE"/>
                 </a:solidFill>
@@ -3904,21 +3810,13 @@
           </a:p>
           <a:p>
             <a:pPr>
-              <a:spcAft>
-                <a:spcPts val="1600"/>
-              </a:spcAft>
-              <a:defRPr sz="2400" b="1">
+              <a:defRPr sz="2200" b="1">
                 <a:solidFill>
                   <a:srgbClr val="FFFFFF"/>
                 </a:solidFill>
               </a:defRPr>
             </a:pPr>
             <a:r>
-              <a:rPr sz="2400" b="1">
-                <a:solidFill>
-                  <a:srgbClr val="00FF87"/>
-                </a:solidFill>
-              </a:rPr>
               <a:t>Data Intelligence</a:t>
             </a:r>
           </a:p>
@@ -3928,27 +3826,14 @@
               <a:spcAft>
                 <a:spcPts val="1400"/>
               </a:spcAft>
-              <a:defRPr sz="2000">
+              <a:defRPr sz="1600">
                 <a:solidFill>
                   <a:srgbClr val="C8C8C8"/>
                 </a:solidFill>
               </a:defRPr>
             </a:pPr>
             <a:r>
-              <a:rPr sz="2000" b="1">
-                <a:solidFill>
-                  <a:srgbClr val="00F2FE"/>
-                </a:solidFill>
-              </a:rPr>
-              <a:t>• Sales Monitoring: </a:t>
-            </a:r>
-            <a:r>
-              <a:rPr sz="2000" b="0">
-                <a:solidFill>
-                  <a:srgbClr val="F1F5F9"/>
-                </a:solidFill>
-              </a:rPr>
-              <a:t>Live KPI cards.</a:t>
+              <a:t>• Sales Monitoring: Live KPI cards.</a:t>
             </a:r>
           </a:p>
           <a:p>
@@ -3956,27 +3841,14 @@
               <a:spcAft>
                 <a:spcPts val="1400"/>
               </a:spcAft>
-              <a:defRPr sz="2000">
+              <a:defRPr sz="1600">
                 <a:solidFill>
                   <a:srgbClr val="C8C8C8"/>
                 </a:solidFill>
               </a:defRPr>
             </a:pPr>
             <a:r>
-              <a:rPr sz="2000" b="1">
-                <a:solidFill>
-                  <a:srgbClr val="00F2FE"/>
-                </a:solidFill>
-              </a:rPr>
-              <a:t>• Visualizations: </a:t>
-            </a:r>
-            <a:r>
-              <a:rPr sz="2000" b="0">
-                <a:solidFill>
-                  <a:srgbClr val="F1F5F9"/>
-                </a:solidFill>
-              </a:rPr>
-              <a:t>Interactive pies and bar graphs.</a:t>
+              <a:t>• Visualizations: Interactive pies and bar graphs.</a:t>
             </a:r>
           </a:p>
           <a:p>
@@ -3984,27 +3856,14 @@
               <a:spcAft>
                 <a:spcPts val="1400"/>
               </a:spcAft>
-              <a:defRPr sz="2000">
+              <a:defRPr sz="1600">
                 <a:solidFill>
                   <a:srgbClr val="C8C8C8"/>
                 </a:solidFill>
               </a:defRPr>
             </a:pPr>
             <a:r>
-              <a:rPr sz="2000" b="1">
-                <a:solidFill>
-                  <a:srgbClr val="00F2FE"/>
-                </a:solidFill>
-              </a:rPr>
-              <a:t>• Timeframe Filtering: </a:t>
-            </a:r>
-            <a:r>
-              <a:rPr sz="2000" b="0">
-                <a:solidFill>
-                  <a:srgbClr val="F1F5F9"/>
-                </a:solidFill>
-              </a:rPr>
-              <a:t>Daily, Weekly, Monthly.</a:t>
+              <a:t>• Timeframe Filtering: Daily, Weekly, Monthly.</a:t>
             </a:r>
           </a:p>
         </p:txBody>
@@ -4147,7 +4006,7 @@
           </a:p>
           <a:p>
             <a:pPr algn="ctr">
-              <a:defRPr sz="3600" b="1">
+              <a:defRPr sz="3200" b="1">
                 <a:solidFill>
                   <a:srgbClr val="00F2FE"/>
                 </a:solidFill>
@@ -4204,21 +4063,13 @@
           </a:p>
           <a:p>
             <a:pPr>
-              <a:spcAft>
-                <a:spcPts val="1600"/>
-              </a:spcAft>
-              <a:defRPr sz="2400" b="1">
+              <a:defRPr sz="2200" b="1">
                 <a:solidFill>
                   <a:srgbClr val="FFFFFF"/>
                 </a:solidFill>
               </a:defRPr>
             </a:pPr>
             <a:r>
-              <a:rPr sz="2400" b="1">
-                <a:solidFill>
-                  <a:srgbClr val="00FF87"/>
-                </a:solidFill>
-              </a:rPr>
               <a:t>Credit Management Dashboard</a:t>
             </a:r>
           </a:p>
@@ -4228,27 +4079,14 @@
               <a:spcAft>
                 <a:spcPts val="1400"/>
               </a:spcAft>
-              <a:defRPr sz="2000">
+              <a:defRPr sz="1600">
                 <a:solidFill>
                   <a:srgbClr val="C8C8C8"/>
                 </a:solidFill>
               </a:defRPr>
             </a:pPr>
             <a:r>
-              <a:rPr sz="2000" b="1">
-                <a:solidFill>
-                  <a:srgbClr val="00F2FE"/>
-                </a:solidFill>
-              </a:rPr>
-              <a:t>• Digital Ledger: </a:t>
-            </a:r>
-            <a:r>
-              <a:rPr sz="2000" b="0">
-                <a:solidFill>
-                  <a:srgbClr val="F1F5F9"/>
-                </a:solidFill>
-              </a:rPr>
-              <a:t>Toggle Given &amp; Received.</a:t>
+              <a:t>• Digital Ledger: Toggle Given &amp; Received.</a:t>
             </a:r>
           </a:p>
           <a:p>
@@ -4256,27 +4094,14 @@
               <a:spcAft>
                 <a:spcPts val="1400"/>
               </a:spcAft>
-              <a:defRPr sz="2000">
+              <a:defRPr sz="1600">
                 <a:solidFill>
                   <a:srgbClr val="C8C8C8"/>
                 </a:solidFill>
               </a:defRPr>
             </a:pPr>
             <a:r>
-              <a:rPr sz="2000" b="1">
-                <a:solidFill>
-                  <a:srgbClr val="00F2FE"/>
-                </a:solidFill>
-              </a:rPr>
-              <a:t>• Due Date Tracking: </a:t>
-            </a:r>
-            <a:r>
-              <a:rPr sz="2000" b="0">
-                <a:solidFill>
-                  <a:srgbClr val="F1F5F9"/>
-                </a:solidFill>
-              </a:rPr>
-              <a:t>Automated high-risk alerts.</a:t>
+              <a:t>• Due Date Tracking: Automated high-risk alerts.</a:t>
             </a:r>
           </a:p>
           <a:p>
@@ -4284,27 +4109,14 @@
               <a:spcAft>
                 <a:spcPts val="1400"/>
               </a:spcAft>
-              <a:defRPr sz="2000">
+              <a:defRPr sz="1600">
                 <a:solidFill>
                   <a:srgbClr val="C8C8C8"/>
                 </a:solidFill>
               </a:defRPr>
             </a:pPr>
             <a:r>
-              <a:rPr sz="2000" b="1">
-                <a:solidFill>
-                  <a:srgbClr val="00F2FE"/>
-                </a:solidFill>
-              </a:rPr>
-              <a:t>• One-Click Follow Up: </a:t>
-            </a:r>
-            <a:r>
-              <a:rPr sz="2000" b="0">
-                <a:solidFill>
-                  <a:srgbClr val="F1F5F9"/>
-                </a:solidFill>
-              </a:rPr>
-              <a:t>WhatsApp links.</a:t>
+              <a:t>• One-Click Follow Up: WhatsApp links.</a:t>
             </a:r>
           </a:p>
         </p:txBody>
@@ -4447,7 +4259,7 @@
           </a:p>
           <a:p>
             <a:pPr algn="ctr">
-              <a:defRPr sz="3600" b="1">
+              <a:defRPr sz="3200" b="1">
                 <a:solidFill>
                   <a:srgbClr val="00F2FE"/>
                 </a:solidFill>
@@ -4504,21 +4316,13 @@
           </a:p>
           <a:p>
             <a:pPr>
-              <a:spcAft>
-                <a:spcPts val="1600"/>
-              </a:spcAft>
-              <a:defRPr sz="2400" b="1">
+              <a:defRPr sz="2200" b="1">
                 <a:solidFill>
                   <a:srgbClr val="FFFFFF"/>
                 </a:solidFill>
               </a:defRPr>
             </a:pPr>
             <a:r>
-              <a:rPr sz="2400" b="1">
-                <a:solidFill>
-                  <a:srgbClr val="00FF87"/>
-                </a:solidFill>
-              </a:rPr>
               <a:t>Live Data Management</a:t>
             </a:r>
           </a:p>
@@ -4528,27 +4332,14 @@
               <a:spcAft>
                 <a:spcPts val="1400"/>
               </a:spcAft>
-              <a:defRPr sz="2000">
+              <a:defRPr sz="1600">
                 <a:solidFill>
                   <a:srgbClr val="C8C8C8"/>
                 </a:solidFill>
               </a:defRPr>
             </a:pPr>
             <a:r>
-              <a:rPr sz="2000" b="1">
-                <a:solidFill>
-                  <a:srgbClr val="00F2FE"/>
-                </a:solidFill>
-              </a:rPr>
-              <a:t>• ACID Storage &amp; Live Editing: </a:t>
-            </a:r>
-            <a:r>
-              <a:rPr sz="2000" b="0">
-                <a:solidFill>
-                  <a:srgbClr val="F1F5F9"/>
-                </a:solidFill>
-              </a:rPr>
-              <a:t>Interactive grid.</a:t>
+              <a:t>• ACID Storage &amp; Live Editing: Interactive grid.</a:t>
             </a:r>
           </a:p>
           <a:p>
@@ -4556,27 +4347,14 @@
               <a:spcAft>
                 <a:spcPts val="1400"/>
               </a:spcAft>
-              <a:defRPr sz="2000">
+              <a:defRPr sz="1600">
                 <a:solidFill>
                   <a:srgbClr val="C8C8C8"/>
                 </a:solidFill>
               </a:defRPr>
             </a:pPr>
             <a:r>
-              <a:rPr sz="2000" b="1">
-                <a:solidFill>
-                  <a:srgbClr val="00F2FE"/>
-                </a:solidFill>
-              </a:rPr>
-              <a:t>• Record Management: </a:t>
-            </a:r>
-            <a:r>
-              <a:rPr sz="2000" b="0">
-                <a:solidFill>
-                  <a:srgbClr val="F1F5F9"/>
-                </a:solidFill>
-              </a:rPr>
-              <a:t>Secure deletions.</a:t>
+              <a:t>• Record Management: Secure deletions.</a:t>
             </a:r>
           </a:p>
           <a:p>
@@ -4584,27 +4362,14 @@
               <a:spcAft>
                 <a:spcPts val="1400"/>
               </a:spcAft>
-              <a:defRPr sz="2000">
+              <a:defRPr sz="1600">
                 <a:solidFill>
                   <a:srgbClr val="C8C8C8"/>
                 </a:solidFill>
               </a:defRPr>
             </a:pPr>
             <a:r>
-              <a:rPr sz="2000" b="1">
-                <a:solidFill>
-                  <a:srgbClr val="00F2FE"/>
-                </a:solidFill>
-              </a:rPr>
-              <a:t>• Multi-Language Export: </a:t>
-            </a:r>
-            <a:r>
-              <a:rPr sz="2000" b="0">
-                <a:solidFill>
-                  <a:srgbClr val="F1F5F9"/>
-                </a:solidFill>
-              </a:rPr>
-              <a:t>CSV or Marathi PDF.</a:t>
+              <a:t>• Multi-Language Export: CSV or Marathi PDF.</a:t>
             </a:r>
           </a:p>
         </p:txBody>
@@ -4747,7 +4512,7 @@
           </a:p>
           <a:p>
             <a:pPr algn="ctr">
-              <a:defRPr sz="3600" b="1">
+              <a:defRPr sz="3200" b="1">
                 <a:solidFill>
                   <a:srgbClr val="00F2FE"/>
                 </a:solidFill>
@@ -4804,21 +4569,13 @@
           </a:p>
           <a:p>
             <a:pPr>
-              <a:spcAft>
-                <a:spcPts val="1600"/>
-              </a:spcAft>
-              <a:defRPr sz="2400" b="1">
+              <a:defRPr sz="2200" b="1">
                 <a:solidFill>
                   <a:srgbClr val="FFFFFF"/>
                 </a:solidFill>
               </a:defRPr>
             </a:pPr>
             <a:r>
-              <a:rPr sz="2400" b="1">
-                <a:solidFill>
-                  <a:srgbClr val="00FF87"/>
-                </a:solidFill>
-              </a:rPr>
               <a:t>Conversational Intelligence</a:t>
             </a:r>
           </a:p>
@@ -4828,27 +4585,14 @@
               <a:spcAft>
                 <a:spcPts val="1400"/>
               </a:spcAft>
-              <a:defRPr sz="2000">
+              <a:defRPr sz="1600">
                 <a:solidFill>
                   <a:srgbClr val="C8C8C8"/>
                 </a:solidFill>
               </a:defRPr>
             </a:pPr>
             <a:r>
-              <a:rPr sz="2000" b="1">
-                <a:solidFill>
-                  <a:srgbClr val="00F2FE"/>
-                </a:solidFill>
-              </a:rPr>
-              <a:t>• Context-Aware Chatbot: </a:t>
-            </a:r>
-            <a:r>
-              <a:rPr sz="2000" b="0">
-                <a:solidFill>
-                  <a:srgbClr val="F1F5F9"/>
-                </a:solidFill>
-              </a:rPr>
-              <a:t>Chat with context.</a:t>
+              <a:t>• Context-Aware Chatbot: Chat with context.</a:t>
             </a:r>
           </a:p>
           <a:p>
@@ -4856,27 +4600,14 @@
               <a:spcAft>
                 <a:spcPts val="1400"/>
               </a:spcAft>
-              <a:defRPr sz="2000">
+              <a:defRPr sz="1600">
                 <a:solidFill>
                   <a:srgbClr val="C8C8C8"/>
                 </a:solidFill>
               </a:defRPr>
             </a:pPr>
             <a:r>
-              <a:rPr sz="2000" b="1">
-                <a:solidFill>
-                  <a:srgbClr val="00F2FE"/>
-                </a:solidFill>
-              </a:rPr>
-              <a:t>• Voice Input: </a:t>
-            </a:r>
-            <a:r>
-              <a:rPr sz="2000" b="0">
-                <a:solidFill>
-                  <a:srgbClr val="F1F5F9"/>
-                </a:solidFill>
-              </a:rPr>
-              <a:t>Ask in Marathi or Hindi.</a:t>
+              <a:t>• Voice Input: Ask in Marathi or Hindi.</a:t>
             </a:r>
           </a:p>
           <a:p>
@@ -4884,27 +4615,14 @@
               <a:spcAft>
                 <a:spcPts val="1400"/>
               </a:spcAft>
-              <a:defRPr sz="2000">
+              <a:defRPr sz="1600">
                 <a:solidFill>
                   <a:srgbClr val="C8C8C8"/>
                 </a:solidFill>
               </a:defRPr>
             </a:pPr>
             <a:r>
-              <a:rPr sz="2000" b="1">
-                <a:solidFill>
-                  <a:srgbClr val="00F2FE"/>
-                </a:solidFill>
-              </a:rPr>
-              <a:t>• Quick Action Chips: </a:t>
-            </a:r>
-            <a:r>
-              <a:rPr sz="2000" b="0">
-                <a:solidFill>
-                  <a:srgbClr val="F1F5F9"/>
-                </a:solidFill>
-              </a:rPr>
-              <a:t>One-tap prompts.</a:t>
+              <a:t>• Quick Action Chips: One-tap prompts.</a:t>
             </a:r>
           </a:p>
         </p:txBody>
@@ -5047,7 +4765,7 @@
           </a:p>
           <a:p>
             <a:pPr algn="ctr">
-              <a:defRPr sz="3600" b="1">
+              <a:defRPr sz="3200" b="1">
                 <a:solidFill>
                   <a:srgbClr val="00F2FE"/>
                 </a:solidFill>
@@ -5104,21 +4822,13 @@
           </a:p>
           <a:p>
             <a:pPr>
-              <a:spcAft>
-                <a:spcPts val="1600"/>
-              </a:spcAft>
-              <a:defRPr sz="2400" b="1">
+              <a:defRPr sz="2200" b="1">
                 <a:solidFill>
                   <a:srgbClr val="FFFFFF"/>
                 </a:solidFill>
               </a:defRPr>
             </a:pPr>
             <a:r>
-              <a:rPr sz="2400" b="1">
-                <a:solidFill>
-                  <a:srgbClr val="00FF87"/>
-                </a:solidFill>
-              </a:rPr>
               <a:t>System Accountability</a:t>
             </a:r>
           </a:p>
@@ -5128,27 +4838,14 @@
               <a:spcAft>
                 <a:spcPts val="1400"/>
               </a:spcAft>
-              <a:defRPr sz="2000">
+              <a:defRPr sz="1600">
                 <a:solidFill>
                   <a:srgbClr val="C8C8C8"/>
                 </a:solidFill>
               </a:defRPr>
             </a:pPr>
             <a:r>
-              <a:rPr sz="2000" b="1">
-                <a:solidFill>
-                  <a:srgbClr val="00F2FE"/>
-                </a:solidFill>
-              </a:rPr>
-              <a:t>• Role Access Setup: </a:t>
-            </a:r>
-            <a:r>
-              <a:rPr sz="2000" b="0">
-                <a:solidFill>
-                  <a:srgbClr val="F1F5F9"/>
-                </a:solidFill>
-              </a:rPr>
-              <a:t>Wizard for Admin or Staff.</a:t>
+              <a:t>• Role Access Setup: Wizard for Admin or Staff.</a:t>
             </a:r>
           </a:p>
           <a:p>
@@ -5156,27 +4853,14 @@
               <a:spcAft>
                 <a:spcPts val="1400"/>
               </a:spcAft>
-              <a:defRPr sz="2000">
+              <a:defRPr sz="1600">
                 <a:solidFill>
                   <a:srgbClr val="C8C8C8"/>
                 </a:solidFill>
               </a:defRPr>
             </a:pPr>
             <a:r>
-              <a:rPr sz="2000" b="1">
-                <a:solidFill>
-                  <a:srgbClr val="00F2FE"/>
-                </a:solidFill>
-              </a:rPr>
-              <a:t>• System Audit Logs: </a:t>
-            </a:r>
-            <a:r>
-              <a:rPr sz="2000" b="0">
-                <a:solidFill>
-                  <a:srgbClr val="F1F5F9"/>
-                </a:solidFill>
-              </a:rPr>
-              <a:t>Tracks 'Who did what'.</a:t>
+              <a:t>• System Audit Logs: Tracks 'Who did what'.</a:t>
             </a:r>
           </a:p>
           <a:p>
@@ -5184,27 +4868,14 @@
               <a:spcAft>
                 <a:spcPts val="1400"/>
               </a:spcAft>
-              <a:defRPr sz="2000">
+              <a:defRPr sz="1600">
                 <a:solidFill>
                   <a:srgbClr val="C8C8C8"/>
                 </a:solidFill>
               </a:defRPr>
             </a:pPr>
             <a:r>
-              <a:rPr sz="2000" b="1">
-                <a:solidFill>
-                  <a:srgbClr val="00F2FE"/>
-                </a:solidFill>
-              </a:rPr>
-              <a:t>• Zero-Trust Security: </a:t>
-            </a:r>
-            <a:r>
-              <a:rPr sz="2000" b="0">
-                <a:solidFill>
-                  <a:srgbClr val="F1F5F9"/>
-                </a:solidFill>
-              </a:rPr>
-              <a:t>Protects core system.</a:t>
+              <a:t>• Zero-Trust Security: Protects core system.</a:t>
             </a:r>
           </a:p>
         </p:txBody>
@@ -5326,7 +4997,7 @@
           <a:p/>
           <a:p>
             <a:pPr algn="ctr">
-              <a:defRPr sz="5800" b="1">
+              <a:defRPr sz="5400" b="1">
                 <a:solidFill>
                   <a:srgbClr val="00F2FE"/>
                 </a:solidFill>

</xml_diff>

<commit_message>
feat: update entire application to yesterday end-of-day state while keeping RAG AI Chat completely untouched
</commit_message>
<xml_diff>
--- a/VernaLedger_Full_Presentation.pptx
+++ b/VernaLedger_Full_Presentation.pptx
@@ -3128,7 +3128,7 @@
           <a:p/>
           <a:p>
             <a:pPr algn="ctr">
-              <a:defRPr sz="6000" b="1">
+              <a:defRPr sz="6200" b="1">
                 <a:solidFill>
                   <a:srgbClr val="00F2FE"/>
                 </a:solidFill>
@@ -3164,7 +3164,7 @@
           <a:p/>
           <a:p>
             <a:pPr algn="ctr">
-              <a:defRPr sz="2800">
+              <a:defRPr sz="3000">
                 <a:solidFill>
                   <a:srgbClr val="00FF87"/>
                 </a:solidFill>
@@ -3247,7 +3247,7 @@
           </a:p>
           <a:p>
             <a:pPr algn="ctr">
-              <a:defRPr sz="3200" b="1">
+              <a:defRPr sz="3600" b="1">
                 <a:solidFill>
                   <a:srgbClr val="00F2FE"/>
                 </a:solidFill>
@@ -3304,13 +3304,21 @@
           </a:p>
           <a:p>
             <a:pPr>
-              <a:defRPr sz="2200" b="1">
+              <a:spcAft>
+                <a:spcPts val="1600"/>
+              </a:spcAft>
+              <a:defRPr sz="2400" b="1">
                 <a:solidFill>
                   <a:srgbClr val="FFFFFF"/>
                 </a:solidFill>
               </a:defRPr>
             </a:pPr>
             <a:r>
+              <a:rPr sz="2400" b="1">
+                <a:solidFill>
+                  <a:srgbClr val="00FF87"/>
+                </a:solidFill>
+              </a:rPr>
               <a:t>Access Management</a:t>
             </a:r>
           </a:p>
@@ -3320,14 +3328,27 @@
               <a:spcAft>
                 <a:spcPts val="1400"/>
               </a:spcAft>
-              <a:defRPr sz="1600">
+              <a:defRPr sz="2000">
                 <a:solidFill>
                   <a:srgbClr val="C8C8C8"/>
                 </a:solidFill>
               </a:defRPr>
             </a:pPr>
             <a:r>
-              <a:t>• Authentication Security: PBKDF2 with SHA-256.</a:t>
+              <a:rPr sz="2000" b="1">
+                <a:solidFill>
+                  <a:srgbClr val="00F2FE"/>
+                </a:solidFill>
+              </a:rPr>
+              <a:t>• Authentication Security: </a:t>
+            </a:r>
+            <a:r>
+              <a:rPr sz="2000" b="0">
+                <a:solidFill>
+                  <a:srgbClr val="F1F5F9"/>
+                </a:solidFill>
+              </a:rPr>
+              <a:t>PBKDF2 with SHA-256.</a:t>
             </a:r>
           </a:p>
           <a:p>
@@ -3335,14 +3356,27 @@
               <a:spcAft>
                 <a:spcPts val="1400"/>
               </a:spcAft>
-              <a:defRPr sz="1600">
+              <a:defRPr sz="2000">
                 <a:solidFill>
                   <a:srgbClr val="C8C8C8"/>
                 </a:solidFill>
               </a:defRPr>
             </a:pPr>
             <a:r>
-              <a:t>• Role-Based Access (RBAC): Admin vs. Staff.</a:t>
+              <a:rPr sz="2000" b="1">
+                <a:solidFill>
+                  <a:srgbClr val="00F2FE"/>
+                </a:solidFill>
+              </a:rPr>
+              <a:t>• Role-Based Access (RBAC): </a:t>
+            </a:r>
+            <a:r>
+              <a:rPr sz="2000" b="0">
+                <a:solidFill>
+                  <a:srgbClr val="F1F5F9"/>
+                </a:solidFill>
+              </a:rPr>
+              <a:t>Admin vs. Staff.</a:t>
             </a:r>
           </a:p>
           <a:p>
@@ -3350,14 +3384,27 @@
               <a:spcAft>
                 <a:spcPts val="1400"/>
               </a:spcAft>
-              <a:defRPr sz="1600">
+              <a:defRPr sz="2000">
                 <a:solidFill>
                   <a:srgbClr val="C8C8C8"/>
                 </a:solidFill>
               </a:defRPr>
             </a:pPr>
             <a:r>
-              <a:t>• Persistent Sessions: Auto-login functionality.</a:t>
+              <a:rPr sz="2000" b="1">
+                <a:solidFill>
+                  <a:srgbClr val="00F2FE"/>
+                </a:solidFill>
+              </a:rPr>
+              <a:t>• Persistent Sessions: </a:t>
+            </a:r>
+            <a:r>
+              <a:rPr sz="2000" b="0">
+                <a:solidFill>
+                  <a:srgbClr val="F1F5F9"/>
+                </a:solidFill>
+              </a:rPr>
+              <a:t>Auto-login functionality.</a:t>
             </a:r>
           </a:p>
         </p:txBody>
@@ -3500,7 +3547,7 @@
           </a:p>
           <a:p>
             <a:pPr algn="ctr">
-              <a:defRPr sz="3200" b="1">
+              <a:defRPr sz="3600" b="1">
                 <a:solidFill>
                   <a:srgbClr val="00F2FE"/>
                 </a:solidFill>
@@ -3557,13 +3604,21 @@
           </a:p>
           <a:p>
             <a:pPr>
-              <a:defRPr sz="2200" b="1">
+              <a:spcAft>
+                <a:spcPts val="1600"/>
+              </a:spcAft>
+              <a:defRPr sz="2400" b="1">
                 <a:solidFill>
                   <a:srgbClr val="FFFFFF"/>
                 </a:solidFill>
               </a:defRPr>
             </a:pPr>
             <a:r>
+              <a:rPr sz="2400" b="1">
+                <a:solidFill>
+                  <a:srgbClr val="00FF87"/>
+                </a:solidFill>
+              </a:rPr>
               <a:t>Core Engine Showcase</a:t>
             </a:r>
           </a:p>
@@ -3573,14 +3628,27 @@
               <a:spcAft>
                 <a:spcPts val="1400"/>
               </a:spcAft>
-              <a:defRPr sz="1600">
+              <a:defRPr sz="2000">
                 <a:solidFill>
                   <a:srgbClr val="C8C8C8"/>
                 </a:solidFill>
               </a:defRPr>
             </a:pPr>
             <a:r>
-              <a:t>• Multimodal Bill Capture: File Upload, Camera, Voice.</a:t>
+              <a:rPr sz="2000" b="1">
+                <a:solidFill>
+                  <a:srgbClr val="00F2FE"/>
+                </a:solidFill>
+              </a:rPr>
+              <a:t>• Multimodal Bill Capture: </a:t>
+            </a:r>
+            <a:r>
+              <a:rPr sz="2000" b="0">
+                <a:solidFill>
+                  <a:srgbClr val="F1F5F9"/>
+                </a:solidFill>
+              </a:rPr>
+              <a:t>File Upload, Camera, Voice.</a:t>
             </a:r>
           </a:p>
           <a:p>
@@ -3588,14 +3656,27 @@
               <a:spcAft>
                 <a:spcPts val="1400"/>
               </a:spcAft>
-              <a:defRPr sz="1600">
+              <a:defRPr sz="2000">
                 <a:solidFill>
                   <a:srgbClr val="C8C8C8"/>
                 </a:solidFill>
               </a:defRPr>
             </a:pPr>
             <a:r>
-              <a:t>• Duplicate Prevention: Automatic warnings.</a:t>
+              <a:rPr sz="2000" b="1">
+                <a:solidFill>
+                  <a:srgbClr val="00F2FE"/>
+                </a:solidFill>
+              </a:rPr>
+              <a:t>• Duplicate Prevention: </a:t>
+            </a:r>
+            <a:r>
+              <a:rPr sz="2000" b="0">
+                <a:solidFill>
+                  <a:srgbClr val="F1F5F9"/>
+                </a:solidFill>
+              </a:rPr>
+              <a:t>Automatic warnings.</a:t>
             </a:r>
           </a:p>
           <a:p>
@@ -3603,14 +3684,27 @@
               <a:spcAft>
                 <a:spcPts val="1400"/>
               </a:spcAft>
-              <a:defRPr sz="1600">
+              <a:defRPr sz="2000">
                 <a:solidFill>
                   <a:srgbClr val="C8C8C8"/>
                 </a:solidFill>
               </a:defRPr>
             </a:pPr>
             <a:r>
-              <a:t>• Audio Confirmation: Edge TTS in Marathi.</a:t>
+              <a:rPr sz="2000" b="1">
+                <a:solidFill>
+                  <a:srgbClr val="00F2FE"/>
+                </a:solidFill>
+              </a:rPr>
+              <a:t>• Audio Confirmation: </a:t>
+            </a:r>
+            <a:r>
+              <a:rPr sz="2000" b="0">
+                <a:solidFill>
+                  <a:srgbClr val="F1F5F9"/>
+                </a:solidFill>
+              </a:rPr>
+              <a:t>Edge TTS in Marathi.</a:t>
             </a:r>
           </a:p>
         </p:txBody>
@@ -3753,7 +3847,7 @@
           </a:p>
           <a:p>
             <a:pPr algn="ctr">
-              <a:defRPr sz="3200" b="1">
+              <a:defRPr sz="3600" b="1">
                 <a:solidFill>
                   <a:srgbClr val="00F2FE"/>
                 </a:solidFill>
@@ -3810,13 +3904,21 @@
           </a:p>
           <a:p>
             <a:pPr>
-              <a:defRPr sz="2200" b="1">
+              <a:spcAft>
+                <a:spcPts val="1600"/>
+              </a:spcAft>
+              <a:defRPr sz="2400" b="1">
                 <a:solidFill>
                   <a:srgbClr val="FFFFFF"/>
                 </a:solidFill>
               </a:defRPr>
             </a:pPr>
             <a:r>
+              <a:rPr sz="2400" b="1">
+                <a:solidFill>
+                  <a:srgbClr val="00FF87"/>
+                </a:solidFill>
+              </a:rPr>
               <a:t>Data Intelligence</a:t>
             </a:r>
           </a:p>
@@ -3826,14 +3928,27 @@
               <a:spcAft>
                 <a:spcPts val="1400"/>
               </a:spcAft>
-              <a:defRPr sz="1600">
+              <a:defRPr sz="2000">
                 <a:solidFill>
                   <a:srgbClr val="C8C8C8"/>
                 </a:solidFill>
               </a:defRPr>
             </a:pPr>
             <a:r>
-              <a:t>• Sales Monitoring: Live KPI cards.</a:t>
+              <a:rPr sz="2000" b="1">
+                <a:solidFill>
+                  <a:srgbClr val="00F2FE"/>
+                </a:solidFill>
+              </a:rPr>
+              <a:t>• Sales Monitoring: </a:t>
+            </a:r>
+            <a:r>
+              <a:rPr sz="2000" b="0">
+                <a:solidFill>
+                  <a:srgbClr val="F1F5F9"/>
+                </a:solidFill>
+              </a:rPr>
+              <a:t>Live KPI cards.</a:t>
             </a:r>
           </a:p>
           <a:p>
@@ -3841,14 +3956,27 @@
               <a:spcAft>
                 <a:spcPts val="1400"/>
               </a:spcAft>
-              <a:defRPr sz="1600">
+              <a:defRPr sz="2000">
                 <a:solidFill>
                   <a:srgbClr val="C8C8C8"/>
                 </a:solidFill>
               </a:defRPr>
             </a:pPr>
             <a:r>
-              <a:t>• Visualizations: Interactive pies and bar graphs.</a:t>
+              <a:rPr sz="2000" b="1">
+                <a:solidFill>
+                  <a:srgbClr val="00F2FE"/>
+                </a:solidFill>
+              </a:rPr>
+              <a:t>• Visualizations: </a:t>
+            </a:r>
+            <a:r>
+              <a:rPr sz="2000" b="0">
+                <a:solidFill>
+                  <a:srgbClr val="F1F5F9"/>
+                </a:solidFill>
+              </a:rPr>
+              <a:t>Interactive pies and bar graphs.</a:t>
             </a:r>
           </a:p>
           <a:p>
@@ -3856,14 +3984,27 @@
               <a:spcAft>
                 <a:spcPts val="1400"/>
               </a:spcAft>
-              <a:defRPr sz="1600">
+              <a:defRPr sz="2000">
                 <a:solidFill>
                   <a:srgbClr val="C8C8C8"/>
                 </a:solidFill>
               </a:defRPr>
             </a:pPr>
             <a:r>
-              <a:t>• Timeframe Filtering: Daily, Weekly, Monthly.</a:t>
+              <a:rPr sz="2000" b="1">
+                <a:solidFill>
+                  <a:srgbClr val="00F2FE"/>
+                </a:solidFill>
+              </a:rPr>
+              <a:t>• Timeframe Filtering: </a:t>
+            </a:r>
+            <a:r>
+              <a:rPr sz="2000" b="0">
+                <a:solidFill>
+                  <a:srgbClr val="F1F5F9"/>
+                </a:solidFill>
+              </a:rPr>
+              <a:t>Daily, Weekly, Monthly.</a:t>
             </a:r>
           </a:p>
         </p:txBody>
@@ -4006,7 +4147,7 @@
           </a:p>
           <a:p>
             <a:pPr algn="ctr">
-              <a:defRPr sz="3200" b="1">
+              <a:defRPr sz="3600" b="1">
                 <a:solidFill>
                   <a:srgbClr val="00F2FE"/>
                 </a:solidFill>
@@ -4063,13 +4204,21 @@
           </a:p>
           <a:p>
             <a:pPr>
-              <a:defRPr sz="2200" b="1">
+              <a:spcAft>
+                <a:spcPts val="1600"/>
+              </a:spcAft>
+              <a:defRPr sz="2400" b="1">
                 <a:solidFill>
                   <a:srgbClr val="FFFFFF"/>
                 </a:solidFill>
               </a:defRPr>
             </a:pPr>
             <a:r>
+              <a:rPr sz="2400" b="1">
+                <a:solidFill>
+                  <a:srgbClr val="00FF87"/>
+                </a:solidFill>
+              </a:rPr>
               <a:t>Credit Management Dashboard</a:t>
             </a:r>
           </a:p>
@@ -4079,14 +4228,27 @@
               <a:spcAft>
                 <a:spcPts val="1400"/>
               </a:spcAft>
-              <a:defRPr sz="1600">
+              <a:defRPr sz="2000">
                 <a:solidFill>
                   <a:srgbClr val="C8C8C8"/>
                 </a:solidFill>
               </a:defRPr>
             </a:pPr>
             <a:r>
-              <a:t>• Digital Ledger: Toggle Given &amp; Received.</a:t>
+              <a:rPr sz="2000" b="1">
+                <a:solidFill>
+                  <a:srgbClr val="00F2FE"/>
+                </a:solidFill>
+              </a:rPr>
+              <a:t>• Digital Ledger: </a:t>
+            </a:r>
+            <a:r>
+              <a:rPr sz="2000" b="0">
+                <a:solidFill>
+                  <a:srgbClr val="F1F5F9"/>
+                </a:solidFill>
+              </a:rPr>
+              <a:t>Toggle Given &amp; Received.</a:t>
             </a:r>
           </a:p>
           <a:p>
@@ -4094,14 +4256,27 @@
               <a:spcAft>
                 <a:spcPts val="1400"/>
               </a:spcAft>
-              <a:defRPr sz="1600">
+              <a:defRPr sz="2000">
                 <a:solidFill>
                   <a:srgbClr val="C8C8C8"/>
                 </a:solidFill>
               </a:defRPr>
             </a:pPr>
             <a:r>
-              <a:t>• Due Date Tracking: Automated high-risk alerts.</a:t>
+              <a:rPr sz="2000" b="1">
+                <a:solidFill>
+                  <a:srgbClr val="00F2FE"/>
+                </a:solidFill>
+              </a:rPr>
+              <a:t>• Due Date Tracking: </a:t>
+            </a:r>
+            <a:r>
+              <a:rPr sz="2000" b="0">
+                <a:solidFill>
+                  <a:srgbClr val="F1F5F9"/>
+                </a:solidFill>
+              </a:rPr>
+              <a:t>Automated high-risk alerts.</a:t>
             </a:r>
           </a:p>
           <a:p>
@@ -4109,14 +4284,27 @@
               <a:spcAft>
                 <a:spcPts val="1400"/>
               </a:spcAft>
-              <a:defRPr sz="1600">
+              <a:defRPr sz="2000">
                 <a:solidFill>
                   <a:srgbClr val="C8C8C8"/>
                 </a:solidFill>
               </a:defRPr>
             </a:pPr>
             <a:r>
-              <a:t>• One-Click Follow Up: WhatsApp links.</a:t>
+              <a:rPr sz="2000" b="1">
+                <a:solidFill>
+                  <a:srgbClr val="00F2FE"/>
+                </a:solidFill>
+              </a:rPr>
+              <a:t>• One-Click Follow Up: </a:t>
+            </a:r>
+            <a:r>
+              <a:rPr sz="2000" b="0">
+                <a:solidFill>
+                  <a:srgbClr val="F1F5F9"/>
+                </a:solidFill>
+              </a:rPr>
+              <a:t>WhatsApp links.</a:t>
             </a:r>
           </a:p>
         </p:txBody>
@@ -4259,7 +4447,7 @@
           </a:p>
           <a:p>
             <a:pPr algn="ctr">
-              <a:defRPr sz="3200" b="1">
+              <a:defRPr sz="3600" b="1">
                 <a:solidFill>
                   <a:srgbClr val="00F2FE"/>
                 </a:solidFill>
@@ -4316,13 +4504,21 @@
           </a:p>
           <a:p>
             <a:pPr>
-              <a:defRPr sz="2200" b="1">
+              <a:spcAft>
+                <a:spcPts val="1600"/>
+              </a:spcAft>
+              <a:defRPr sz="2400" b="1">
                 <a:solidFill>
                   <a:srgbClr val="FFFFFF"/>
                 </a:solidFill>
               </a:defRPr>
             </a:pPr>
             <a:r>
+              <a:rPr sz="2400" b="1">
+                <a:solidFill>
+                  <a:srgbClr val="00FF87"/>
+                </a:solidFill>
+              </a:rPr>
               <a:t>Live Data Management</a:t>
             </a:r>
           </a:p>
@@ -4332,14 +4528,27 @@
               <a:spcAft>
                 <a:spcPts val="1400"/>
               </a:spcAft>
-              <a:defRPr sz="1600">
+              <a:defRPr sz="2000">
                 <a:solidFill>
                   <a:srgbClr val="C8C8C8"/>
                 </a:solidFill>
               </a:defRPr>
             </a:pPr>
             <a:r>
-              <a:t>• ACID Storage &amp; Live Editing: Interactive grid.</a:t>
+              <a:rPr sz="2000" b="1">
+                <a:solidFill>
+                  <a:srgbClr val="00F2FE"/>
+                </a:solidFill>
+              </a:rPr>
+              <a:t>• ACID Storage &amp; Live Editing: </a:t>
+            </a:r>
+            <a:r>
+              <a:rPr sz="2000" b="0">
+                <a:solidFill>
+                  <a:srgbClr val="F1F5F9"/>
+                </a:solidFill>
+              </a:rPr>
+              <a:t>Interactive grid.</a:t>
             </a:r>
           </a:p>
           <a:p>
@@ -4347,14 +4556,27 @@
               <a:spcAft>
                 <a:spcPts val="1400"/>
               </a:spcAft>
-              <a:defRPr sz="1600">
+              <a:defRPr sz="2000">
                 <a:solidFill>
                   <a:srgbClr val="C8C8C8"/>
                 </a:solidFill>
               </a:defRPr>
             </a:pPr>
             <a:r>
-              <a:t>• Record Management: Secure deletions.</a:t>
+              <a:rPr sz="2000" b="1">
+                <a:solidFill>
+                  <a:srgbClr val="00F2FE"/>
+                </a:solidFill>
+              </a:rPr>
+              <a:t>• Record Management: </a:t>
+            </a:r>
+            <a:r>
+              <a:rPr sz="2000" b="0">
+                <a:solidFill>
+                  <a:srgbClr val="F1F5F9"/>
+                </a:solidFill>
+              </a:rPr>
+              <a:t>Secure deletions.</a:t>
             </a:r>
           </a:p>
           <a:p>
@@ -4362,14 +4584,27 @@
               <a:spcAft>
                 <a:spcPts val="1400"/>
               </a:spcAft>
-              <a:defRPr sz="1600">
+              <a:defRPr sz="2000">
                 <a:solidFill>
                   <a:srgbClr val="C8C8C8"/>
                 </a:solidFill>
               </a:defRPr>
             </a:pPr>
             <a:r>
-              <a:t>• Multi-Language Export: CSV or Marathi PDF.</a:t>
+              <a:rPr sz="2000" b="1">
+                <a:solidFill>
+                  <a:srgbClr val="00F2FE"/>
+                </a:solidFill>
+              </a:rPr>
+              <a:t>• Multi-Language Export: </a:t>
+            </a:r>
+            <a:r>
+              <a:rPr sz="2000" b="0">
+                <a:solidFill>
+                  <a:srgbClr val="F1F5F9"/>
+                </a:solidFill>
+              </a:rPr>
+              <a:t>CSV or Marathi PDF.</a:t>
             </a:r>
           </a:p>
         </p:txBody>
@@ -4512,7 +4747,7 @@
           </a:p>
           <a:p>
             <a:pPr algn="ctr">
-              <a:defRPr sz="3200" b="1">
+              <a:defRPr sz="3600" b="1">
                 <a:solidFill>
                   <a:srgbClr val="00F2FE"/>
                 </a:solidFill>
@@ -4569,13 +4804,21 @@
           </a:p>
           <a:p>
             <a:pPr>
-              <a:defRPr sz="2200" b="1">
+              <a:spcAft>
+                <a:spcPts val="1600"/>
+              </a:spcAft>
+              <a:defRPr sz="2400" b="1">
                 <a:solidFill>
                   <a:srgbClr val="FFFFFF"/>
                 </a:solidFill>
               </a:defRPr>
             </a:pPr>
             <a:r>
+              <a:rPr sz="2400" b="1">
+                <a:solidFill>
+                  <a:srgbClr val="00FF87"/>
+                </a:solidFill>
+              </a:rPr>
               <a:t>Conversational Intelligence</a:t>
             </a:r>
           </a:p>
@@ -4585,14 +4828,27 @@
               <a:spcAft>
                 <a:spcPts val="1400"/>
               </a:spcAft>
-              <a:defRPr sz="1600">
+              <a:defRPr sz="2000">
                 <a:solidFill>
                   <a:srgbClr val="C8C8C8"/>
                 </a:solidFill>
               </a:defRPr>
             </a:pPr>
             <a:r>
-              <a:t>• Context-Aware Chatbot: Chat with context.</a:t>
+              <a:rPr sz="2000" b="1">
+                <a:solidFill>
+                  <a:srgbClr val="00F2FE"/>
+                </a:solidFill>
+              </a:rPr>
+              <a:t>• Context-Aware Chatbot: </a:t>
+            </a:r>
+            <a:r>
+              <a:rPr sz="2000" b="0">
+                <a:solidFill>
+                  <a:srgbClr val="F1F5F9"/>
+                </a:solidFill>
+              </a:rPr>
+              <a:t>Chat with context.</a:t>
             </a:r>
           </a:p>
           <a:p>
@@ -4600,14 +4856,27 @@
               <a:spcAft>
                 <a:spcPts val="1400"/>
               </a:spcAft>
-              <a:defRPr sz="1600">
+              <a:defRPr sz="2000">
                 <a:solidFill>
                   <a:srgbClr val="C8C8C8"/>
                 </a:solidFill>
               </a:defRPr>
             </a:pPr>
             <a:r>
-              <a:t>• Voice Input: Ask in Marathi or Hindi.</a:t>
+              <a:rPr sz="2000" b="1">
+                <a:solidFill>
+                  <a:srgbClr val="00F2FE"/>
+                </a:solidFill>
+              </a:rPr>
+              <a:t>• Voice Input: </a:t>
+            </a:r>
+            <a:r>
+              <a:rPr sz="2000" b="0">
+                <a:solidFill>
+                  <a:srgbClr val="F1F5F9"/>
+                </a:solidFill>
+              </a:rPr>
+              <a:t>Ask in Marathi or Hindi.</a:t>
             </a:r>
           </a:p>
           <a:p>
@@ -4615,14 +4884,27 @@
               <a:spcAft>
                 <a:spcPts val="1400"/>
               </a:spcAft>
-              <a:defRPr sz="1600">
+              <a:defRPr sz="2000">
                 <a:solidFill>
                   <a:srgbClr val="C8C8C8"/>
                 </a:solidFill>
               </a:defRPr>
             </a:pPr>
             <a:r>
-              <a:t>• Quick Action Chips: One-tap prompts.</a:t>
+              <a:rPr sz="2000" b="1">
+                <a:solidFill>
+                  <a:srgbClr val="00F2FE"/>
+                </a:solidFill>
+              </a:rPr>
+              <a:t>• Quick Action Chips: </a:t>
+            </a:r>
+            <a:r>
+              <a:rPr sz="2000" b="0">
+                <a:solidFill>
+                  <a:srgbClr val="F1F5F9"/>
+                </a:solidFill>
+              </a:rPr>
+              <a:t>One-tap prompts.</a:t>
             </a:r>
           </a:p>
         </p:txBody>
@@ -4765,7 +5047,7 @@
           </a:p>
           <a:p>
             <a:pPr algn="ctr">
-              <a:defRPr sz="3200" b="1">
+              <a:defRPr sz="3600" b="1">
                 <a:solidFill>
                   <a:srgbClr val="00F2FE"/>
                 </a:solidFill>
@@ -4822,13 +5104,21 @@
           </a:p>
           <a:p>
             <a:pPr>
-              <a:defRPr sz="2200" b="1">
+              <a:spcAft>
+                <a:spcPts val="1600"/>
+              </a:spcAft>
+              <a:defRPr sz="2400" b="1">
                 <a:solidFill>
                   <a:srgbClr val="FFFFFF"/>
                 </a:solidFill>
               </a:defRPr>
             </a:pPr>
             <a:r>
+              <a:rPr sz="2400" b="1">
+                <a:solidFill>
+                  <a:srgbClr val="00FF87"/>
+                </a:solidFill>
+              </a:rPr>
               <a:t>System Accountability</a:t>
             </a:r>
           </a:p>
@@ -4838,14 +5128,27 @@
               <a:spcAft>
                 <a:spcPts val="1400"/>
               </a:spcAft>
-              <a:defRPr sz="1600">
+              <a:defRPr sz="2000">
                 <a:solidFill>
                   <a:srgbClr val="C8C8C8"/>
                 </a:solidFill>
               </a:defRPr>
             </a:pPr>
             <a:r>
-              <a:t>• Role Access Setup: Wizard for Admin or Staff.</a:t>
+              <a:rPr sz="2000" b="1">
+                <a:solidFill>
+                  <a:srgbClr val="00F2FE"/>
+                </a:solidFill>
+              </a:rPr>
+              <a:t>• Role Access Setup: </a:t>
+            </a:r>
+            <a:r>
+              <a:rPr sz="2000" b="0">
+                <a:solidFill>
+                  <a:srgbClr val="F1F5F9"/>
+                </a:solidFill>
+              </a:rPr>
+              <a:t>Wizard for Admin or Staff.</a:t>
             </a:r>
           </a:p>
           <a:p>
@@ -4853,14 +5156,27 @@
               <a:spcAft>
                 <a:spcPts val="1400"/>
               </a:spcAft>
-              <a:defRPr sz="1600">
+              <a:defRPr sz="2000">
                 <a:solidFill>
                   <a:srgbClr val="C8C8C8"/>
                 </a:solidFill>
               </a:defRPr>
             </a:pPr>
             <a:r>
-              <a:t>• System Audit Logs: Tracks 'Who did what'.</a:t>
+              <a:rPr sz="2000" b="1">
+                <a:solidFill>
+                  <a:srgbClr val="00F2FE"/>
+                </a:solidFill>
+              </a:rPr>
+              <a:t>• System Audit Logs: </a:t>
+            </a:r>
+            <a:r>
+              <a:rPr sz="2000" b="0">
+                <a:solidFill>
+                  <a:srgbClr val="F1F5F9"/>
+                </a:solidFill>
+              </a:rPr>
+              <a:t>Tracks 'Who did what'.</a:t>
             </a:r>
           </a:p>
           <a:p>
@@ -4868,14 +5184,27 @@
               <a:spcAft>
                 <a:spcPts val="1400"/>
               </a:spcAft>
-              <a:defRPr sz="1600">
+              <a:defRPr sz="2000">
                 <a:solidFill>
                   <a:srgbClr val="C8C8C8"/>
                 </a:solidFill>
               </a:defRPr>
             </a:pPr>
             <a:r>
-              <a:t>• Zero-Trust Security: Protects core system.</a:t>
+              <a:rPr sz="2000" b="1">
+                <a:solidFill>
+                  <a:srgbClr val="00F2FE"/>
+                </a:solidFill>
+              </a:rPr>
+              <a:t>• Zero-Trust Security: </a:t>
+            </a:r>
+            <a:r>
+              <a:rPr sz="2000" b="0">
+                <a:solidFill>
+                  <a:srgbClr val="F1F5F9"/>
+                </a:solidFill>
+              </a:rPr>
+              <a:t>Protects core system.</a:t>
             </a:r>
           </a:p>
         </p:txBody>
@@ -4997,7 +5326,7 @@
           <a:p/>
           <a:p>
             <a:pPr algn="ctr">
-              <a:defRPr sz="5400" b="1">
+              <a:defRPr sz="5800" b="1">
                 <a:solidFill>
                   <a:srgbClr val="00F2FE"/>
                 </a:solidFill>

</xml_diff>